<commit_message>
Tighten smoke fallback scopes and refresh admin analytics smoke
</commit_message>
<xml_diff>
--- a/docs/guardrails/aidlc-hooks-overview.pptx
+++ b/docs/guardrails/aidlc-hooks-overview.pptx
@@ -1700,7 +1700,7 @@
                 <a:ea typeface="Aptos" pitchFamily="34" charset="-122"/>
                 <a:cs typeface="Aptos" pitchFamily="34" charset="-120"/>
               </a:rPr>
-              <a:t>Staged snapshot + push ref diff + full smoke fallback</a:t>
+              <a:t>Staged snapshot + push ref diff + scope-aware smoke fallback</a:t>
             </a:r>
             <a:endParaRPr lang="en-US" sz="1600" dirty="0"/>
           </a:p>
@@ -2144,7 +2144,7 @@
                 <a:ea typeface="Aptos" pitchFamily="34" charset="-122"/>
                 <a:cs typeface="Aptos" pitchFamily="34" charset="-120"/>
               </a:rPr>
-              <a:t>metadata/harness/runner 변경 시 전체 smoke set 실행</a:t>
+              <a:t>metadata/harness/runner 변경 시 scope-aware smoke 승격</a:t>
             </a:r>
             <a:endParaRPr lang="en-US" sz="1200" dirty="0"/>
           </a:p>
@@ -3100,7 +3100,7 @@
                 <a:ea typeface="Aptos Mono" pitchFamily="34" charset="-122"/>
                 <a:cs typeface="Aptos Mono" pitchFamily="34" charset="-120"/>
               </a:rPr>
-              <a:t>      -&gt; metadata or smoke runner config면 full smoke set</a:t>
+              <a:t>      -&gt; metadata or smoke runner config면 scoped smoke set</a:t>
             </a:r>
             <a:endParaRPr lang="en-US" sz="1500" dirty="0"/>
           </a:p>
@@ -3377,7 +3377,7 @@
                 <a:ea typeface="Aptos" pitchFamily="34" charset="-122"/>
                 <a:cs typeface="Aptos" pitchFamily="34" charset="-120"/>
               </a:rPr>
-              <a:t>metadata/harness/runner 변경이면 전체 smoke set으로 안전하게 승격</a:t>
+              <a:t>metadata/harness/runner 변경이면 관련 scope smoke만 승격</a:t>
             </a:r>
             <a:endParaRPr lang="en-US" sz="1200" dirty="0"/>
           </a:p>
@@ -3842,7 +3842,7 @@
                 <a:ea typeface="Aptos" pitchFamily="34" charset="-122"/>
                 <a:cs typeface="Aptos" pitchFamily="34" charset="-120"/>
               </a:rPr>
-              <a:t>pre-push는 smoke mapping layer가 바뀌면 targeted smoke 대신 full smoke로 승격한다.</a:t>
+              <a:t>pre-push는 smoke mapping layer가 바뀌면 targeted smoke 대신 scope-aware smoke로 승격한다.</a:t>
             </a:r>
             <a:endParaRPr lang="en-US" sz="1200" dirty="0"/>
           </a:p>
@@ -4794,7 +4794,7 @@
                 <a:ea typeface="Aptos" pitchFamily="34" charset="-122"/>
                 <a:cs typeface="Aptos" pitchFamily="34" charset="-120"/>
               </a:rPr>
-              <a:t>2. contract metadata나 smoke harness를 바꿨다면 targeted smoke가 아니라 full smoke까지 각오한다.</a:t>
+              <a:t>2. contract metadata나 smoke harness를 바꿨다면 targeted smoke가 아니라 관련 scope smoke까지 각오한다.</a:t>
             </a:r>
             <a:endParaRPr lang="en-US" sz="1800" dirty="0"/>
           </a:p>

</xml_diff>

<commit_message>
feat: add metadata-driven smoke registry
</commit_message>
<xml_diff>
--- a/docs/guardrails/aidlc-hooks-overview.pptx
+++ b/docs/guardrails/aidlc-hooks-overview.pptx
@@ -1993,7 +1993,7 @@
                 <a:ea typeface="Aptos" pitchFamily="34" charset="-122"/>
                 <a:cs typeface="Aptos" pitchFamily="34" charset="-120"/>
               </a:rPr>
-              <a:t>guardrail config 변경 시 전체 validate + audit 수행</a:t>
+              <a:t>metadata와 generated smoke registry drift도 commit 전에 검증</a:t>
             </a:r>
             <a:endParaRPr lang="en-US" sz="1200" dirty="0"/>
           </a:p>
@@ -2144,7 +2144,7 @@
                 <a:ea typeface="Aptos" pitchFamily="34" charset="-122"/>
                 <a:cs typeface="Aptos" pitchFamily="34" charset="-120"/>
               </a:rPr>
-              <a:t>metadata/harness/runner 변경 시 scope-aware smoke 승격</a:t>
+              <a:t>metadata/doc/runner/generated registry 변경 시 scope-aware smoke 승격</a:t>
             </a:r>
             <a:endParaRPr lang="en-US" sz="1200" dirty="0"/>
           </a:p>
@@ -2338,7 +2338,7 @@
                 <a:ea typeface="Aptos" pitchFamily="34" charset="-122"/>
                 <a:cs typeface="Aptos" pitchFamily="34" charset="-120"/>
               </a:rPr>
-              <a:t>핵심은 guarded source만이 아니라 metadata/harness/runner 같은 guardrail 자체 변경도 놓치지 않는 것이다.</a:t>
+              <a:t>핵심은 guarded source만이 아니라 metadata/harness/runner/canonical smoke doc 같은 guardrail 자체 변경도 놓치지 않는 것이다.</a:t>
             </a:r>
             <a:endParaRPr lang="en-US" sz="1500" dirty="0"/>
           </a:p>
@@ -2828,6 +2828,27 @@
             </a:r>
             <a:endParaRPr lang="en-US" sz="1200" dirty="0"/>
           </a:p>
+          <a:p>
+            <a:pPr marL="177800" indent="-177800">
+              <a:spcAft>
+                <a:spcPts val="1000"/>
+              </a:spcAft>
+              <a:buSzPct val="100000"/>
+              <a:buChar char="•"/>
+            </a:pPr>
+            <a:r>
+              <a:rPr lang="en-US" sz="1200" dirty="0">
+                <a:solidFill>
+                  <a:srgbClr val="20313F"/>
+                </a:solidFill>
+                <a:latin typeface="Aptos" pitchFamily="34" charset="0"/>
+                <a:ea typeface="Aptos" pitchFamily="34" charset="-122"/>
+                <a:cs typeface="Aptos" pitchFamily="34" charset="-120"/>
+              </a:rPr>
+              <a:t>smoke registry generated file이 stale이면 커밋 전에 바로 막는다.</a:t>
+            </a:r>
+            <a:endParaRPr lang="en-US" sz="1200" dirty="0"/>
+          </a:p>
         </p:txBody>
       </p:sp>
       <p:sp>
@@ -3100,7 +3121,7 @@
                 <a:ea typeface="Aptos Mono" pitchFamily="34" charset="-122"/>
                 <a:cs typeface="Aptos Mono" pitchFamily="34" charset="-120"/>
               </a:rPr>
-              <a:t>      -&gt; metadata or smoke runner config면 scoped smoke set</a:t>
+              <a:t>      -&gt; metadata or smoke/doc/runner config면 scoped smoke set</a:t>
             </a:r>
             <a:endParaRPr lang="en-US" sz="1500" dirty="0"/>
           </a:p>
@@ -3649,7 +3670,7 @@
                 <a:ea typeface="Aptos" pitchFamily="34" charset="-122"/>
                 <a:cs typeface="Aptos" pitchFamily="34" charset="-120"/>
               </a:rPr>
-              <a:t>`tests/client/contracts/*.ts`, `tests/client/featureContracts.ts`</a:t>
+              <a:t>`tests/client/contracts/*.ts`, `tests/client/contracts/smoke-specs/**/*.md`</a:t>
             </a:r>
             <a:endParaRPr lang="en-US" sz="1200" dirty="0"/>
           </a:p>
@@ -3670,6 +3691,27 @@
                 <a:ea typeface="Aptos" pitchFamily="34" charset="-122"/>
                 <a:cs typeface="Aptos" pitchFamily="34" charset="-120"/>
               </a:rPr>
+              <a:t>`tests/client/featureContracts.ts`, `tests/client/smokeRegistry.generated.ts`</a:t>
+            </a:r>
+            <a:endParaRPr lang="en-US" sz="1200" dirty="0"/>
+          </a:p>
+          <a:p>
+            <a:pPr marL="177800" indent="-177800">
+              <a:spcAft>
+                <a:spcPts val="1000"/>
+              </a:spcAft>
+              <a:buSzPct val="100000"/>
+              <a:buChar char="•"/>
+            </a:pPr>
+            <a:r>
+              <a:rPr lang="en-US" sz="1200" dirty="0">
+                <a:solidFill>
+                  <a:srgbClr val="20313F"/>
+                </a:solidFill>
+                <a:latin typeface="Aptos" pitchFamily="34" charset="0"/>
+                <a:ea typeface="Aptos" pitchFamily="34" charset="-122"/>
+                <a:cs typeface="Aptos" pitchFamily="34" charset="-120"/>
+              </a:rPr>
               <a:t>`tests/client/fixtures/*SmokeHarness.ts`</a:t>
             </a:r>
             <a:endParaRPr lang="en-US" sz="1200" dirty="0"/>
@@ -3691,7 +3733,28 @@
                 <a:ea typeface="Aptos" pitchFamily="34" charset="-122"/>
                 <a:cs typeface="Aptos" pitchFamily="34" charset="-120"/>
               </a:rPr>
-              <a:t>`tests/client/runSmoke.ts`, `scripts/smoke*.ts`</a:t>
+              <a:t>`tests/client/runSmoke.ts`, `scripts/generateSmokeRegistry.mjs`</a:t>
+            </a:r>
+            <a:endParaRPr lang="en-US" sz="1200" dirty="0"/>
+          </a:p>
+          <a:p>
+            <a:pPr marL="177800" indent="-177800">
+              <a:spcAft>
+                <a:spcPts val="1000"/>
+              </a:spcAft>
+              <a:buSzPct val="100000"/>
+              <a:buChar char="•"/>
+            </a:pPr>
+            <a:r>
+              <a:rPr lang="en-US" sz="1200" dirty="0">
+                <a:solidFill>
+                  <a:srgbClr val="20313F"/>
+                </a:solidFill>
+                <a:latin typeface="Aptos" pitchFamily="34" charset="0"/>
+                <a:ea typeface="Aptos" pitchFamily="34" charset="-122"/>
+                <a:cs typeface="Aptos" pitchFamily="34" charset="-120"/>
+              </a:rPr>
+              <a:t>`scripts/listSmokeRegistryContractIds.ts`, `scripts/smoke*.ts`</a:t>
             </a:r>
             <a:endParaRPr lang="en-US" sz="1200" dirty="0"/>
           </a:p>
@@ -3842,7 +3905,7 @@
                 <a:ea typeface="Aptos" pitchFamily="34" charset="-122"/>
                 <a:cs typeface="Aptos" pitchFamily="34" charset="-120"/>
               </a:rPr>
-              <a:t>pre-push는 smoke mapping layer가 바뀌면 targeted smoke 대신 scope-aware smoke로 승격한다.</a:t>
+              <a:t>pre-push는 smoke mapping layer나 canonical doc linkage가 바뀌면 targeted smoke 대신 scope-aware smoke로 승격한다.</a:t>
             </a:r>
             <a:endParaRPr lang="en-US" sz="1200" dirty="0"/>
           </a:p>
@@ -4441,6 +4504,27 @@
             </a:r>
             <a:endParaRPr lang="en-US" sz="1200" dirty="0"/>
           </a:p>
+          <a:p>
+            <a:pPr marL="177800" indent="-177800">
+              <a:spcAft>
+                <a:spcPts val="1000"/>
+              </a:spcAft>
+              <a:buSzPct val="100000"/>
+              <a:buChar char="•"/>
+            </a:pPr>
+            <a:r>
+              <a:rPr lang="en-US" sz="1200" dirty="0">
+                <a:solidFill>
+                  <a:srgbClr val="20313F"/>
+                </a:solidFill>
+                <a:latin typeface="Aptos" pitchFamily="34" charset="0"/>
+                <a:ea typeface="Aptos" pitchFamily="34" charset="-122"/>
+                <a:cs typeface="Aptos" pitchFamily="34" charset="-120"/>
+              </a:rPr>
+              <a:t>`tests/client/contracts/smoke-specs/**`</a:t>
+            </a:r>
+            <a:endParaRPr lang="en-US" sz="1200" dirty="0"/>
+          </a:p>
         </p:txBody>
       </p:sp>
       <p:sp>
@@ -4547,6 +4631,27 @@
                 <a:cs typeface="Aptos" pitchFamily="34" charset="-120"/>
               </a:rPr>
               <a:t>`tests/client/runSmoke.ts`</a:t>
+            </a:r>
+            <a:endParaRPr lang="en-US" sz="1200" dirty="0"/>
+          </a:p>
+          <a:p>
+            <a:pPr marL="177800" indent="-177800">
+              <a:spcAft>
+                <a:spcPts val="1000"/>
+              </a:spcAft>
+              <a:buSzPct val="100000"/>
+              <a:buChar char="•"/>
+            </a:pPr>
+            <a:r>
+              <a:rPr lang="en-US" sz="1200" dirty="0">
+                <a:solidFill>
+                  <a:srgbClr val="20313F"/>
+                </a:solidFill>
+                <a:latin typeface="Aptos" pitchFamily="34" charset="0"/>
+                <a:ea typeface="Aptos" pitchFamily="34" charset="-122"/>
+                <a:cs typeface="Aptos" pitchFamily="34" charset="-120"/>
+              </a:rPr>
+              <a:t>`tests/client/smokeRegistry.generated.ts`</a:t>
             </a:r>
             <a:endParaRPr lang="en-US" sz="1200" dirty="0"/>
           </a:p>
@@ -4794,7 +4899,7 @@
                 <a:ea typeface="Aptos" pitchFamily="34" charset="-122"/>
                 <a:cs typeface="Aptos" pitchFamily="34" charset="-120"/>
               </a:rPr>
-              <a:t>2. contract metadata나 smoke harness를 바꿨다면 targeted smoke가 아니라 관련 scope smoke까지 각오한다.</a:t>
+              <a:t>2. smoke runner나 canonical smoke doc를 바꿨다면 metadata와 generated registry를 같이 갱신한다.</a:t>
             </a:r>
             <a:endParaRPr lang="en-US" sz="1800" dirty="0"/>
           </a:p>
@@ -4815,7 +4920,7 @@
                 <a:ea typeface="Aptos" pitchFamily="34" charset="-122"/>
                 <a:cs typeface="Aptos" pitchFamily="34" charset="-120"/>
               </a:rPr>
-              <a:t>3. 다른 branch/ref로 push할 때도 pre-push가 실제 stdin ref를 읽는다는 전제를 유지한다.</a:t>
+              <a:t>3. contract metadata나 smoke harness를 바꿨다면 targeted smoke가 아니라 관련 scope smoke까지 각오한다.</a:t>
             </a:r>
             <a:endParaRPr lang="en-US" sz="1800" dirty="0"/>
           </a:p>
@@ -4836,7 +4941,7 @@
                 <a:ea typeface="Aptos" pitchFamily="34" charset="-122"/>
                 <a:cs typeface="Aptos" pitchFamily="34" charset="-120"/>
               </a:rPr>
-              <a:t>4. local hook을 우회할 수 있어도 CI가 같은 verify script를 다시 돌린다는 점을 문서에 남긴다.</a:t>
+              <a:t>4. 다른 branch/ref로 push할 때도 pre-push가 실제 stdin ref를 읽는다는 전제를 유지한다.</a:t>
             </a:r>
             <a:endParaRPr lang="en-US" sz="1800" dirty="0"/>
           </a:p>
@@ -4857,7 +4962,28 @@
                 <a:ea typeface="Aptos" pitchFamily="34" charset="-122"/>
                 <a:cs typeface="Aptos" pitchFamily="34" charset="-120"/>
               </a:rPr>
-              <a:t>5. hook을 더 바꿀 때는 `tests/scripts/aidlcHookUtils.test.mjs` 같은 순수 규칙 테스트도 같이 갱신한다.</a:t>
+              <a:t>5. local hook을 우회할 수 있어도 CI가 같은 verify script를 다시 돌린다는 점을 문서에 남긴다.</a:t>
+            </a:r>
+            <a:endParaRPr lang="en-US" sz="1800" dirty="0"/>
+          </a:p>
+          <a:p>
+            <a:pPr marL="177800" indent="-177800">
+              <a:spcAft>
+                <a:spcPts val="1000"/>
+              </a:spcAft>
+              <a:buSzPct val="100000"/>
+              <a:buChar char="•"/>
+            </a:pPr>
+            <a:r>
+              <a:rPr lang="en-US" sz="1800" dirty="0">
+                <a:solidFill>
+                  <a:srgbClr val="20313F"/>
+                </a:solidFill>
+                <a:latin typeface="Aptos" pitchFamily="34" charset="0"/>
+                <a:ea typeface="Aptos" pitchFamily="34" charset="-122"/>
+                <a:cs typeface="Aptos" pitchFamily="34" charset="-120"/>
+              </a:rPr>
+              <a:t>6. hook을 더 바꿀 때는 `tests/scripts/aidlcHookUtils.test.mjs`와 smoke registry 테스트를 같이 갱신한다.</a:t>
             </a:r>
             <a:endParaRPr lang="en-US" sz="1800" dirty="0"/>
           </a:p>
@@ -5085,6 +5211,48 @@
                 <a:cs typeface="Aptos" pitchFamily="34" charset="-120"/>
               </a:rPr>
               <a:t>scripts/aidlcHookUtils.mjs</a:t>
+            </a:r>
+            <a:endParaRPr lang="en-US" sz="1800" dirty="0"/>
+          </a:p>
+          <a:p>
+            <a:pPr marL="177800" indent="-177800">
+              <a:spcAft>
+                <a:spcPts val="1000"/>
+              </a:spcAft>
+              <a:buSzPct val="100000"/>
+              <a:buChar char="•"/>
+            </a:pPr>
+            <a:r>
+              <a:rPr lang="en-US" sz="1800" dirty="0">
+                <a:solidFill>
+                  <a:srgbClr val="20313F"/>
+                </a:solidFill>
+                <a:latin typeface="Aptos" pitchFamily="34" charset="0"/>
+                <a:ea typeface="Aptos" pitchFamily="34" charset="-122"/>
+                <a:cs typeface="Aptos" pitchFamily="34" charset="-120"/>
+              </a:rPr>
+              <a:t>scripts/generateSmokeRegistry.mjs</a:t>
+            </a:r>
+            <a:endParaRPr lang="en-US" sz="1800" dirty="0"/>
+          </a:p>
+          <a:p>
+            <a:pPr marL="177800" indent="-177800">
+              <a:spcAft>
+                <a:spcPts val="1000"/>
+              </a:spcAft>
+              <a:buSzPct val="100000"/>
+              <a:buChar char="•"/>
+            </a:pPr>
+            <a:r>
+              <a:rPr lang="en-US" sz="1800" dirty="0">
+                <a:solidFill>
+                  <a:srgbClr val="20313F"/>
+                </a:solidFill>
+                <a:latin typeface="Aptos" pitchFamily="34" charset="0"/>
+                <a:ea typeface="Aptos" pitchFamily="34" charset="-122"/>
+                <a:cs typeface="Aptos" pitchFamily="34" charset="-120"/>
+              </a:rPr>
+              <a:t>scripts/smokeRegistrySupport.mjs</a:t>
             </a:r>
             <a:endParaRPr lang="en-US" sz="1800" dirty="0"/>
           </a:p>

</xml_diff>